<commit_message>
feat: add core frontend pages, navigation, and temporarily bypass authentication for guest access
</commit_message>
<xml_diff>
--- a/AI-Plant-Disease-Detection.pptx
+++ b/AI-Plant-Disease-Detection.pptx
@@ -15,6 +15,7 @@
     <p:sldId id="260" r:id="rId6"/>
     <p:sldId id="261" r:id="rId7"/>
     <p:sldId id="262" r:id="rId8"/>
+    <p:sldId id="263" r:id="rId14"/>
   </p:sldIdLst>
   <p:sldSz cx="12192000" cy="6858000"/>
   <p:notesSz cx="6858000" cy="12192000"/>
@@ -9514,6 +9515,287 @@
               <a:t>Master Plant Disease Dataset (overlaps existing sources) · two sugarcane sets (taxonomy conflict, suspected pre-augmentation) · pre-augmented and pre-split folders (train–test leakage) · the mustard set that carried Indonesian fruit-ripeness labels.</a:t>
             </a:r>
             <a:endParaRPr lang="en-US" sz="1000" dirty="0"/>
+          </a:p>
+        </p:txBody>
+      </p:sp>
+    </p:spTree>
+  </p:cSld>
+  <p:clrMapOvr>
+    <a:masterClrMapping/>
+  </p:clrMapOvr>
+</p:sld>
+</file>
+
+<file path=ppt/slides/slide8.xml><?xml version="1.0" encoding="utf-8"?>
+<p:sld xmlns:a="http://schemas.openxmlformats.org/drawingml/2006/main" xmlns:r="http://schemas.openxmlformats.org/officeDocument/2006/relationships" xmlns:p="http://schemas.openxmlformats.org/presentationml/2006/main">
+  <p:cSld name="Slide 8">
+    <p:bg>
+      <p:bgPr>
+        <a:solidFill>
+          <a:srgbClr val="13251B"/>
+        </a:solidFill>
+        <a:effectLst/>
+      </p:bgPr>
+    </p:bg>
+    <p:spTree>
+      <p:nvGrpSpPr>
+        <p:cNvPr id="1" name=""/>
+        <p:cNvGrpSpPr/>
+        <p:nvPr/>
+      </p:nvGrpSpPr>
+      <p:grpSpPr>
+        <a:xfrm>
+          <a:off x="0" y="0"/>
+          <a:ext cx="0" cy="0"/>
+          <a:chOff x="0" y="0"/>
+          <a:chExt cx="0" cy="0"/>
+        </a:xfrm>
+      </p:grpSpPr>
+      <p:sp>
+        <p:nvSpPr>
+          <p:cNvPr id="2" name="Text 0"/>
+          <p:cNvSpPr txBox="1"/>
+          <p:nvPr/>
+        </p:nvSpPr>
+        <p:spPr>
+          <a:xfrm>
+            <a:off x="493776" y="329184"/>
+            <a:ext cx="7315200" cy="274320"/>
+          </a:xfrm>
+          <a:prstGeom prst="rect">
+            <a:avLst/>
+          </a:prstGeom>
+          <a:noFill/>
+          <a:ln/>
+        </p:spPr>
+        <p:txBody>
+          <a:bodyPr wrap="square" lIns="0" tIns="0" rIns="0" bIns="0" rtlCol="0" anchor="ctr"/>
+          <a:lstStyle/>
+          <a:p>
+            <a:pPr marL="0" indent="0">
+              <a:buNone/>
+            </a:pPr>
+            <a:r>
+              <a:rPr lang="en-US" sz="1100" b="1" kern="0" spc="200" dirty="0">
+                <a:solidFill>
+                  <a:srgbClr val="DB7A3E"/>
+                </a:solidFill>
+                <a:latin typeface="Calibri" pitchFamily="34" charset="0"/>
+                <a:ea typeface="Calibri" pitchFamily="34" charset="-122"/>
+                <a:cs typeface="Calibri" pitchFamily="34" charset="-120"/>
+              </a:rPr>
+              <a:t>07  —  THANK YOU</a:t>
+            </a:r>
+            <a:endParaRPr lang="en-US" sz="1100" dirty="0"/>
+          </a:p>
+        </p:txBody>
+      </p:sp>
+      <p:sp>
+        <p:nvSpPr>
+          <p:cNvPr id="3" name="Shape 1"/>
+          <p:cNvSpPr/>
+          <p:nvPr/>
+        </p:nvSpPr>
+        <p:spPr>
+          <a:xfrm>
+            <a:off x="493776" y="2404872"/>
+            <a:ext cx="310896" cy="310896"/>
+          </a:xfrm>
+          <a:prstGeom prst="ellipse">
+            <a:avLst/>
+          </a:prstGeom>
+          <a:solidFill>
+            <a:srgbClr val="B4531F"/>
+          </a:solidFill>
+          <a:ln/>
+        </p:spPr>
+      </p:sp>
+      <p:sp>
+        <p:nvSpPr>
+          <p:cNvPr id="4" name="Text 2"/>
+          <p:cNvSpPr txBox="1"/>
+          <p:nvPr/>
+        </p:nvSpPr>
+        <p:spPr>
+          <a:xfrm>
+            <a:off x="457200" y="2712720"/>
+            <a:ext cx="11247120" cy="1188720"/>
+          </a:xfrm>
+          <a:prstGeom prst="rect">
+            <a:avLst/>
+          </a:prstGeom>
+          <a:noFill/>
+          <a:ln/>
+        </p:spPr>
+        <p:txBody>
+          <a:bodyPr wrap="square" lIns="0" tIns="0" rIns="0" bIns="0" rtlCol="0" anchor="ctr"/>
+          <a:lstStyle/>
+          <a:p>
+            <a:pPr marL="0" indent="0">
+              <a:buNone/>
+            </a:pPr>
+            <a:r>
+              <a:rPr lang="en-US" sz="6000" b="1" dirty="0">
+                <a:solidFill>
+                  <a:srgbClr val="FFFFFF"/>
+                </a:solidFill>
+                <a:latin typeface="Cambria" pitchFamily="34" charset="0"/>
+                <a:ea typeface="Cambria" pitchFamily="34" charset="-122"/>
+                <a:cs typeface="Cambria" pitchFamily="34" charset="-120"/>
+              </a:rPr>
+              <a:t>Thank you</a:t>
+            </a:r>
+            <a:endParaRPr lang="en-US" sz="6000" dirty="0"/>
+          </a:p>
+        </p:txBody>
+      </p:sp>
+      <p:sp>
+        <p:nvSpPr>
+          <p:cNvPr id="5" name="Text 3"/>
+          <p:cNvSpPr txBox="1"/>
+          <p:nvPr/>
+        </p:nvSpPr>
+        <p:spPr>
+          <a:xfrm>
+            <a:off x="457200" y="4023360"/>
+            <a:ext cx="10515600" cy="365760"/>
+          </a:xfrm>
+          <a:prstGeom prst="rect">
+            <a:avLst/>
+          </a:prstGeom>
+          <a:noFill/>
+          <a:ln/>
+        </p:spPr>
+        <p:txBody>
+          <a:bodyPr wrap="square" lIns="0" tIns="0" rIns="0" bIns="0" rtlCol="0" anchor="ctr"/>
+          <a:lstStyle/>
+          <a:p>
+            <a:pPr marL="0" indent="0">
+              <a:buNone/>
+            </a:pPr>
+            <a:r>
+              <a:rPr lang="en-US" sz="1600" dirty="0">
+                <a:solidFill>
+                  <a:srgbClr val="9DB0A2"/>
+                </a:solidFill>
+                <a:latin typeface="Calibri" pitchFamily="34" charset="0"/>
+                <a:ea typeface="Calibri" pitchFamily="34" charset="-122"/>
+                <a:cs typeface="Calibri" pitchFamily="34" charset="-120"/>
+              </a:rPr>
+              <a:t>Disease diagnosis, severity grading and yield-loss estimation for six Indian field crops</a:t>
+            </a:r>
+            <a:endParaRPr lang="en-US" sz="1600" dirty="0"/>
+          </a:p>
+        </p:txBody>
+      </p:sp>
+      <p:sp>
+        <p:nvSpPr>
+          <p:cNvPr id="6" name="Text 4"/>
+          <p:cNvSpPr txBox="1"/>
+          <p:nvPr/>
+        </p:nvSpPr>
+        <p:spPr>
+          <a:xfrm>
+            <a:off x="457200" y="4526280"/>
+            <a:ext cx="10515600" cy="274320"/>
+          </a:xfrm>
+          <a:prstGeom prst="rect">
+            <a:avLst/>
+          </a:prstGeom>
+          <a:noFill/>
+          <a:ln/>
+        </p:spPr>
+        <p:txBody>
+          <a:bodyPr wrap="square" lIns="0" tIns="0" rIns="0" bIns="0" rtlCol="0" anchor="ctr"/>
+          <a:lstStyle/>
+          <a:p>
+            <a:pPr marL="0" indent="0">
+              <a:buNone/>
+            </a:pPr>
+            <a:r>
+              <a:rPr lang="en-US" sz="1200" dirty="0">
+                <a:solidFill>
+                  <a:srgbClr val="9DB0A2"/>
+                </a:solidFill>
+                <a:latin typeface="Calibri" pitchFamily="34" charset="0"/>
+                <a:ea typeface="Calibri" pitchFamily="34" charset="-122"/>
+                <a:cs typeface="Calibri" pitchFamily="34" charset="-120"/>
+              </a:rPr>
+              <a:t>Questions are welcome.</a:t>
+            </a:r>
+            <a:endParaRPr lang="en-US" sz="1200" dirty="0"/>
+          </a:p>
+        </p:txBody>
+      </p:sp>
+      <p:sp>
+        <p:nvSpPr>
+          <p:cNvPr id="7" name="Shape 5"/>
+          <p:cNvSpPr/>
+          <p:nvPr/>
+        </p:nvSpPr>
+        <p:spPr>
+          <a:xfrm>
+            <a:off x="548640" y="5532120"/>
+            <a:ext cx="11091672" cy="713232"/>
+          </a:xfrm>
+          <a:prstGeom prst="roundRect">
+            <a:avLst>
+              <a:gd name="adj" fmla="val 5128"/>
+            </a:avLst>
+          </a:prstGeom>
+          <a:solidFill>
+            <a:srgbClr val="1E3427"/>
+          </a:solidFill>
+          <a:ln/>
+        </p:spPr>
+      </p:sp>
+      <p:sp>
+        <p:nvSpPr>
+          <p:cNvPr id="8" name="Text 6"/>
+          <p:cNvSpPr txBox="1"/>
+          <p:nvPr/>
+        </p:nvSpPr>
+        <p:spPr>
+          <a:xfrm>
+            <a:off x="822960" y="5532120"/>
+            <a:ext cx="10561320" cy="713232"/>
+          </a:xfrm>
+          <a:prstGeom prst="rect">
+            <a:avLst/>
+          </a:prstGeom>
+          <a:noFill/>
+          <a:ln/>
+        </p:spPr>
+        <p:txBody>
+          <a:bodyPr wrap="square" lIns="0" tIns="0" rIns="0" bIns="0" rtlCol="0" anchor="ctr"/>
+          <a:lstStyle/>
+          <a:p>
+            <a:pPr marL="0" indent="0">
+              <a:buNone/>
+            </a:pPr>
+            <a:r>
+              <a:rPr lang="en-US" sz="1000" b="1" kern="0" spc="100" dirty="0">
+                <a:solidFill>
+                  <a:srgbClr val="DB7A3E"/>
+                </a:solidFill>
+                <a:latin typeface="Calibri" pitchFamily="34" charset="0"/>
+                <a:ea typeface="Calibri" pitchFamily="34" charset="-122"/>
+                <a:cs typeface="Calibri" pitchFamily="34" charset="-120"/>
+              </a:rPr>
+              <a:t>Project team   </a:t>
+            </a:r>
+            <a:r>
+              <a:rPr lang="en-US" sz="1050" dirty="0">
+                <a:solidFill>
+                  <a:srgbClr val="9DB0A2"/>
+                </a:solidFill>
+                <a:latin typeface="Calibri" pitchFamily="34" charset="0"/>
+                <a:ea typeface="Calibri" pitchFamily="34" charset="-122"/>
+                <a:cs typeface="Calibri" pitchFamily="34" charset="-120"/>
+              </a:rPr>
+              <a:t>Anshu Mishra · Anshul Yadav · Anshuman Mishra · Anu Kushwaha       Guided by Mr. Gaurav Kumar Srivastava</a:t>
+            </a:r>
+            <a:endParaRPr lang="en-US" sz="1050" dirty="0"/>
           </a:p>
         </p:txBody>
       </p:sp>

</xml_diff>